<commit_message>
feat: embed live vercel url and qr code in presentation assets
</commit_message>
<xml_diff>
--- a/SIH26092_AI_Scheme_Matching.pptx
+++ b/SIH26092_AI_Scheme_Matching.pptx
@@ -3587,6 +3587,40 @@
               <a:t> UdyamSetu AI (Voice-First Discovery &amp; Automated Micro-DPR Engine)</a:t>
             </a:r>
           </a:p>
+          <a:p>
+            <a:pPr>
+              <a:spcAft>
+                <a:spcPts val="1100"/>
+              </a:spcAft>
+            </a:pPr>
+            <a:r>
+              <a:rPr sz="1400" b="1">
+                <a:solidFill>
+                  <a:srgbClr val="1E1E1E"/>
+                </a:solidFill>
+                <a:latin typeface="Calibri"/>
+              </a:rPr>
+              <a:t>• </a:t>
+            </a:r>
+            <a:r>
+              <a:rPr sz="1400" b="1">
+                <a:solidFill>
+                  <a:srgbClr val="1E1E1E"/>
+                </a:solidFill>
+                <a:latin typeface="Calibri"/>
+              </a:rPr>
+              <a:t>Live Deployed Platform –</a:t>
+            </a:r>
+            <a:r>
+              <a:rPr sz="1400" b="0">
+                <a:solidFill>
+                  <a:srgbClr val="0E4E94"/>
+                </a:solidFill>
+                <a:latin typeface="Calibri"/>
+              </a:rPr>
+              <a:t> https://sih-2026-gold-gamma.vercel.app/</a:t>
+            </a:r>
+          </a:p>
         </p:txBody>
       </p:sp>
     </p:spTree>
@@ -4523,7 +4557,7 @@
               </a:defRPr>
             </a:pPr>
             <a:r>
-              <a:t>PoC Validated with 12+ Micro-Enterprise Trades</a:t>
+              <a:t>Live on Vercel: https://sih-2026-gold-gamma.vercel.app/</a:t>
             </a:r>
           </a:p>
         </p:txBody>
@@ -7136,7 +7170,7 @@
           <a:lstStyle/>
           <a:p>
             <a:pPr algn="ctr">
-              <a:defRPr sz="950" b="1">
+              <a:defRPr sz="900" b="1">
                 <a:solidFill>
                   <a:srgbClr val="0E4E94"/>
                 </a:solidFill>
@@ -7144,7 +7178,7 @@
               </a:defRPr>
             </a:pPr>
             <a:r>
-              <a:t>⚡ Key Architecture: Zero-Hallucination Isolation (NLP separate from Math) | PoC Validated</a:t>
+              <a:t>⚡ Live Platform: https://sih-2026-gold-gamma.vercel.app/ | 100% Zero-Hallucination Architecture</a:t>
             </a:r>
           </a:p>
         </p:txBody>

</xml_diff>

<commit_message>
feat: sync updated PPT, PDF, and QR code pointing to udyamsetu-ai.vercel.app
</commit_message>
<xml_diff>
--- a/SIH26092_AI_Scheme_Matching.pptx
+++ b/SIH26092_AI_Scheme_Matching.pptx
@@ -3618,7 +3618,7 @@
                 </a:solidFill>
                 <a:latin typeface="Calibri"/>
               </a:rPr>
-              <a:t> https://sih-2026-gold-gamma.vercel.app/</a:t>
+              <a:t> https://udyamsetu-ai.vercel.app</a:t>
             </a:r>
           </a:p>
         </p:txBody>
@@ -4557,7 +4557,7 @@
               </a:defRPr>
             </a:pPr>
             <a:r>
-              <a:t>Live on Vercel: https://sih-2026-gold-gamma.vercel.app/</a:t>
+              <a:t>Live on Vercel: https://udyamsetu-ai.vercel.app</a:t>
             </a:r>
           </a:p>
         </p:txBody>
@@ -7178,7 +7178,7 @@
               </a:defRPr>
             </a:pPr>
             <a:r>
-              <a:t>⚡ Live Platform: https://sih-2026-gold-gamma.vercel.app/ | 100% Zero-Hallucination Architecture</a:t>
+              <a:t>⚡ Live Platform: https://udyamsetu-ai.vercel.app | 100% Zero-Hallucination Architecture</a:t>
             </a:r>
           </a:p>
         </p:txBody>

</xml_diff>